<commit_message>
Rewrite repetitive contrast-style titles on slides 1, 9, 11, 12
Co-Authored-By: Claude Opus 5.5 <noreply@anthropic.com>
Claude-Session: https://claude.ai/code/session_01LNckV4PF1WFWnv5VJ442kU
</commit_message>
<xml_diff>
--- a/두드림_11월_쿠팡_지마켓_11번가_수정.pptx
+++ b/두드림_11월_쿠팡_지마켓_11번가_수정.pptx
@@ -1078,7 +1078,7 @@
                 <a:ea typeface="에이투지체 8 ExtraBold"/>
                 <a:cs typeface="에이투지체 8 ExtraBold"/>
               </a:rPr>
-              <a:t>쿠팡 주력 상품은 로켓과 리뷰를 갖췄지만</a:t>
+              <a:t>쿠팡 주력 상품이 핵심 검색어 첫 화면에 없습니다</a:t>
             </a:r>
           </a:p>
           <a:p>
@@ -1096,7 +1096,7 @@
                 <a:ea typeface="에이투지체 8 ExtraBold"/>
                 <a:cs typeface="에이투지체 8 ExtraBold"/>
               </a:rPr>
-              <a:t>핵심 검색어 첫 화면에서는 보이지 않습니다</a:t>
+              <a:t>로켓배송과 리뷰는 이미 갖춘 상태입니다</a:t>
             </a:r>
           </a:p>
         </p:txBody>
@@ -3196,7 +3196,7 @@
                 <a:ea typeface="에이투지체 8 ExtraBold"/>
                 <a:cs typeface="에이투지체 8 ExtraBold"/>
               </a:rPr>
-              <a:t>미니샵에는 아이클타임 상품이 많지만</a:t>
+              <a:t>광고 영역에는 FGO와 프로바이오키드 위주로 노출되고</a:t>
             </a:r>
           </a:p>
           <a:p>
@@ -3214,7 +3214,7 @@
                 <a:ea typeface="에이투지체 8 ExtraBold"/>
                 <a:cs typeface="에이투지체 8 ExtraBold"/>
               </a:rPr>
-              <a:t>광고 영역에는 일부만 노출되고 있습니다</a:t>
+              <a:t>미니샵의 다른 아이클타임 상품은 대부분 빠져 있습니다</a:t>
             </a:r>
           </a:p>
         </p:txBody>
@@ -3920,7 +3920,7 @@
                 <a:ea typeface="에이투지체 8 ExtraBold"/>
                 <a:cs typeface="에이투지체 8 ExtraBold"/>
               </a:rPr>
-              <a:t>대표 검색어에서도 노출은 되지만</a:t>
+              <a:t>대표 검색어에 노출된 두드림 상품은 리뷰가 한 자릿수이고</a:t>
             </a:r>
           </a:p>
           <a:p>
@@ -3938,7 +3938,7 @@
                 <a:ea typeface="에이투지체 8 ExtraBold"/>
                 <a:cs typeface="에이투지체 8 ExtraBold"/>
               </a:rPr>
-              <a:t>리뷰 수천~수만 개 경쟁 상품 사이에 있습니다</a:t>
+              <a:t>주변 경쟁 상품은 리뷰가 수천~수만 개입니다</a:t>
             </a:r>
           </a:p>
         </p:txBody>
@@ -23075,18 +23075,7 @@
                 <a:ea typeface="에이투지체 8 ExtraBold"/>
                 <a:cs typeface="에이투지체 8 ExtraBold"/>
               </a:rPr>
-              <a:t>지마켓은 광고를 운영 중이지만</a:t>
-            </a:r>
-            <a:r>
-              <a:rPr sz="1900" b="0">
-                <a:solidFill>
-                  <a:srgbClr val="222222"/>
-                </a:solidFill>
-                <a:latin typeface="에이투지체 8 ExtraBold"/>
-                <a:ea typeface="에이투지체 8 ExtraBold"/>
-                <a:cs typeface="에이투지체 8 ExtraBold"/>
-              </a:rPr>
-              <a:t> 노출 상품이 적고</a:t>
+              <a:t>지마켓은 광고 상품이 일부에 그치고</a:t>
             </a:r>
           </a:p>
           <a:p>
@@ -23104,7 +23093,7 @@
                 <a:ea typeface="에이투지체 8 ExtraBold"/>
                 <a:cs typeface="에이투지체 8 ExtraBold"/>
               </a:rPr>
-              <a:t>11번가는 광고 영역에서 보이지 않습니다</a:t>
+              <a:t>11번가는 광고 영역에 아예 보이지 않습니다</a:t>
             </a:r>
           </a:p>
         </p:txBody>

</xml_diff>